<commit_message>
Cover division everywhere: checks, results and all documents
- --exhaustive now includes DIV: 7,140 trees, 294 divide-by-zero trees
  skipped, 13,692 runs, 0 failures; --suite adds (a + b) / c (11/11);
  --bench random trees include DIV
- results/ regenerated; README numbers and rule tables updated
- Review 3 report, slides (+ PDF), presenter notes and code guide
  updated for DIV: rule counts 11/17, 33/33 tests, new cost and
  benchmark figures, new line numbers, '%' as the unsupported-operator
  example, division-by-zero handling, defect D7

Co-Authored-By: Claude Opus 5.5 <noreply@anthropic.com>
</commit_message>
<xml_diff>
--- a/docs/Review3_Presentation.pptx
+++ b/docs/Review3_Presentation.pptx
@@ -143,7 +143,7 @@
                 </a:solidFill>
                 <a:latin typeface="Calibri"/>
               </a:rPr>
-              <a:t>Average cover cost over 3,333 trees (lower is better)</a:t>
+              <a:t>Average cover cost over 6,846 trees (lower is better)</a:t>
             </a:r>
           </a:p>
         </c:rich>
@@ -218,13 +218,13 @@
                 <c:formatCode>General</c:formatCode>
                 <c:ptCount val="3"/>
                 <c:pt idx="0">
-                  <c:v>7.26</c:v>
+                  <c:v>8.49</c:v>
                 </c:pt>
                 <c:pt idx="1">
-                  <c:v>6.88</c:v>
+                  <c:v>8.05</c:v>
                 </c:pt>
                 <c:pt idx="2">
-                  <c:v>5.55</c:v>
+                  <c:v>6.72</c:v>
                 </c:pt>
               </c:numCache>
             </c:numRef>
@@ -296,7 +296,7 @@
       <c:valAx>
         <c:axId val="-2113994440"/>
         <c:scaling>
-          <c:max val="8.0"/>
+          <c:max val="10.0"/>
           <c:min val="0.0"/>
         </c:scaling>
         <c:delete val="0"/>
@@ -452,19 +452,19 @@
                   <c:v>9.9</c:v>
                 </c:pt>
                 <c:pt idx="1">
-                  <c:v>9.5</c:v>
+                  <c:v>11.3</c:v>
                 </c:pt>
                 <c:pt idx="2">
-                  <c:v>11.2</c:v>
+                  <c:v>14.2</c:v>
                 </c:pt>
                 <c:pt idx="3">
-                  <c:v>13.0</c:v>
+                  <c:v>15.1</c:v>
                 </c:pt>
                 <c:pt idx="4">
-                  <c:v>13.4</c:v>
+                  <c:v>14.9</c:v>
                 </c:pt>
                 <c:pt idx="5">
-                  <c:v>14.7</c:v>
+                  <c:v>17.3</c:v>
                 </c:pt>
               </c:numCache>
             </c:numRef>
@@ -537,22 +537,22 @@
                 <c:formatCode>General</c:formatCode>
                 <c:ptCount val="6"/>
                 <c:pt idx="0">
-                  <c:v>9.9</c:v>
+                  <c:v>12.3</c:v>
                 </c:pt>
                 <c:pt idx="1">
-                  <c:v>12.0</c:v>
+                  <c:v>13.2</c:v>
                 </c:pt>
                 <c:pt idx="2">
-                  <c:v>15.0</c:v>
+                  <c:v>19.3</c:v>
                 </c:pt>
                 <c:pt idx="3">
-                  <c:v>15.6</c:v>
+                  <c:v>17.5</c:v>
                 </c:pt>
                 <c:pt idx="4">
-                  <c:v>16.1</c:v>
+                  <c:v>18.1</c:v>
                 </c:pt>
                 <c:pt idx="5">
-                  <c:v>17.0</c:v>
+                  <c:v>21.1</c:v>
                 </c:pt>
               </c:numCache>
             </c:numRef>
@@ -1212,7 +1212,7 @@
           <a:lstStyle/>
           <a:p>
             <a:r>
-              <a:t>AHMAD (about 1.5 min). Two independent oracles. First, regression: tests/run_tests.sh runs 25 cases and compares the complete output, stdout, stderr and exit status, byte for byte with tests/expected. Any change in a cover, a cost, an instruction or an error message fails. Second, semantics: every generated program is executed by the simulator for its ISA and must equal the IR's own evaluation. The cases cover positive, boundary, rule choice and negative inputs, plus the 10-expression suite and the exhaustive check of every tree up to depth 2. Result: 27 of 27 pass.</a:t>
+              <a:t>AHMAD (about 1.5 min). Two independent oracles. First, regression: tests/run_tests.sh runs 31 cases and compares the complete output, stdout, stderr and exit status, byte for byte with tests/expected. Any change in a cover, a cost, an instruction or an error message fails. Second, semantics: every generated program is executed by the simulator for its ISA and must equal the IR's own evaluation. The cases cover positive, boundary, rule choice and negative inputs, plus the 11-expression suite and the exhaustive check of every tree up to depth 2, including division. Result: 33 of 33 pass.</a:t>
             </a:r>
           </a:p>
         </p:txBody>
@@ -1282,7 +1282,7 @@
           <a:lstStyle/>
           <a:p>
             <a:r>
-              <a:t>AHMAD (about 2 min). Left: over all 3,333 small trees, a naive selector that emits one instruction per node averages cost 7.26. BURS averages 6.88 on Target A, 5.2 percent lower, and 5.55 on Target B, 23.6 percent lower. B gains more because its memory and immediate operands absorb the right operand of most binary nodes. BURS is never worse, because the naive cover is always one of the covers it considers. Right: labeling time per node stays between about 10 and 17 nanoseconds while the tree grows from 405 to almost 240,000 nodes: linear time, as expected from one table lookup per node. All 6,666 programs were correct.</a:t>
+              <a:t>AHMAD (about 2 min). Left: over the 6,846 small trees that have a value (the other 294 divide by zero), a naive selector that emits one instruction per node averages cost 8.49. BURS averages 8.05 on Target A, 5.1 percent lower, and 6.72 on Target B, 20.9 percent lower. B gains more because its memory and immediate operands absorb the right operand of most binary nodes. BURS is never worse, because the naive cover is always one of the covers it considers. Right: labeling time per node stays between about 9 and 21 nanoseconds while the tree grows from 405 to almost 240,000 nodes: linear time, as expected from one table lookup per node. All 13,692 programs were correct.</a:t>
             </a:r>
           </a:p>
         </p:txBody>
@@ -1982,7 +1982,7 @@
           <a:lstStyle/>
           <a:p>
             <a:r>
-              <a:t>VINEET (about 1 min). At Review 2, Target B was not started, the emitter for it was the open defect D3, the regression suite covered only Target A, and there was no team repository. All of these are closed. Target B is a 14-rule stack machine, tests went from six manual expressions to 27 automated checks, and the repository is public with every review document. Two register numbers remain to be added on the cover page. Scope is unchanged from Review 1.</a:t>
+              <a:t>VINEET (about 1 min). At Review 2, Target B was not started, the emitter for it was the open defect D3, the regression suite covered only Target A, and there was no team repository. All of these are closed. Target B is a stack machine, now 17 rules, tests went from six manual expressions to 33 automated checks, and the repository is public with every review document. Two register numbers remain to be added on the cover page. Scope is unchanged from Review 1.</a:t>
             </a:r>
           </a:p>
         </p:txBody>
@@ -2192,7 +2192,7 @@
           <a:lstStyle/>
           <a:p>
             <a:r>
-              <a:t>MAYANK (about 2.5 min). Both grammars use the same terminals, so they read the same IR. Target A is a three-address register machine with 9 rules: values live in reg, and constants can also be imm so they fold into ADDI and SUBI. Target B is a stack machine with 14 rules and three nonterminals: stk is on the stack, mem is a variable used as a memory operand, imm is a constant. The chain rules stk: mem and stk: imm are the PUSH instructions. Costs: one per instruction, multiplies cost two. Rule numbers are the external numbers the emitter switches on.</a:t>
+              <a:t>MAYANK (about 2.5 min). Both grammars use the same terminals, so they read the same IR. Target A is a three-address register machine with 11 rules: values live in reg, and constants can also be imm so they fold into ADDI, SUBI and DIVI. Target B is a stack machine with 17 rules and three nonterminals: stk is on the stack, mem is a variable used as a memory operand, imm is a constant. The chain rules stk: mem and stk: imm are the PUSH instructions. Costs: one per instruction, multiplies two, divides three. Division was added last: one IR operator and one rule group per grammar, with no engine change. Rule numbers are the external numbers the emitter switches on.</a:t>
             </a:r>
           </a:p>
         </p:txBody>
@@ -2262,7 +2262,7 @@
           <a:lstStyle/>
           <a:p>
             <a:r>
-              <a:t>MAYANK (about 2 min). Live: ./build/burs -t A "a + 7" picks ADDI, cost 2, not LOADI plus ADD at 3. On Target B, a * b becomes PUSH then MULM, cost 3, not two pushes and a MUL at 4. An honest limitation: 7 + a on Target A does not fold, because we have no commutative rule ADD(imm, reg); that is a one-line grammar extension. Error input: a / b is rejected by the parser with the column number and exit status 2, before any selection happens.</a:t>
+              <a:t>MAYANK (about 2 min). Live: ./build/burs -t A "a + 7" picks ADDI, cost 2, not LOADI plus ADD at 3. On Target B, a * b becomes PUSH then MULM, cost 3, not two pushes and a MUL at 4. An honest limitation: 7 + a on Target A does not fold, because we have no commutative rule ADD(imm, reg); that is a one-line grammar extension. Error input: a % b is rejected by the parser with the column number and exit status 2, before any selection happens. (Division itself is supported: a / b gives PUSH, DIVM on Target B.)</a:t>
             </a:r>
           </a:p>
         </p:txBody>
@@ -8635,7 +8635,7 @@
                 </a:solidFill>
                 <a:latin typeface="Calibri"/>
               </a:rPr>
-              <a:t>27 / 27</a:t>
+              <a:t>33 / 33</a:t>
             </a:r>
           </a:p>
         </p:txBody>
@@ -8759,7 +8759,7 @@
                 </a:solidFill>
                 <a:latin typeface="Calibri"/>
               </a:rPr>
-              <a:t>6,666</a:t>
+              <a:t>13,692</a:t>
             </a:r>
           </a:p>
         </p:txBody>
@@ -8883,7 +8883,7 @@
                 </a:solidFill>
                 <a:latin typeface="Calibri"/>
               </a:rPr>
-              <a:t>3,333</a:t>
+              <a:t>7,140</a:t>
             </a:r>
           </a:p>
         </p:txBody>
@@ -8922,7 +8922,7 @@
                 </a:solidFill>
                 <a:latin typeface="Calibri"/>
               </a:rPr>
-              <a:t>distinct trees of depth ≤ 2</a:t>
+              <a:t>trees of depth ≤ 2, incl. DIV</a:t>
             </a:r>
           </a:p>
         </p:txBody>
@@ -9046,7 +9046,7 @@
                 </a:solidFill>
                 <a:latin typeface="Calibri"/>
               </a:rPr>
-              <a:t>6</a:t>
+              <a:t>8</a:t>
             </a:r>
           </a:p>
         </p:txBody>
@@ -9085,7 +9085,7 @@
                 </a:solidFill>
                 <a:latin typeface="Calibri"/>
               </a:rPr>
-              <a:t>the review expressions on both targets: tree, cover, cost, code, simulation</a:t>
+              <a:t>review expressions and division on both targets: tree, cover, cost, code</a:t>
             </a:r>
           </a:p>
         </p:txBody>
@@ -9209,7 +9209,7 @@
                 </a:solidFill>
                 <a:latin typeface="Calibri"/>
               </a:rPr>
-              <a:t>6</a:t>
+              <a:t>7</a:t>
             </a:r>
           </a:p>
         </p:txBody>
@@ -9248,7 +9248,7 @@
                 </a:solidFill>
                 <a:latin typeface="Calibri"/>
               </a:rPr>
-              <a:t>single leaf, 20-variable deep nesting, nested loads, named vars, large constants</a:t>
+              <a:t>single leaf, deep nesting, nested loads, named vars, big constants, -7 / 2</a:t>
             </a:r>
           </a:p>
         </p:txBody>
@@ -9372,7 +9372,7 @@
                 </a:solidFill>
                 <a:latin typeface="Calibri"/>
               </a:rPr>
-              <a:t>5</a:t>
+              <a:t>7</a:t>
             </a:r>
           </a:p>
         </p:txBody>
@@ -9411,7 +9411,7 @@
                 </a:solidFill>
                 <a:latin typeface="Calibri"/>
               </a:rPr>
-              <a:t>ADDI, SUBI, MULM, MULI chosen; 7 + a documents the missing commutative rule</a:t>
+              <a:t>ADDI, SUBI, MULM, MULI, DIVI, DIVM chosen; 7 + a: no commutative rule</a:t>
             </a:r>
           </a:p>
         </p:txBody>
@@ -9496,7 +9496,7 @@
                 </a:solidFill>
                 <a:latin typeface="Calibri"/>
               </a:rPr>
-              <a:t>Negative</a:t>
+              <a:t>Negative + failure</a:t>
             </a:r>
           </a:p>
         </p:txBody>
@@ -9535,7 +9535,7 @@
                 </a:solidFill>
                 <a:latin typeface="Calibri"/>
               </a:rPr>
-              <a:t>8</a:t>
+              <a:t>8 + 1</a:t>
             </a:r>
           </a:p>
         </p:txBody>
@@ -9574,7 +9574,7 @@
                 </a:solidFill>
                 <a:latin typeface="Calibri"/>
               </a:rPr>
-              <a:t>/, missing operand, unbalanced ( and [, trailing token, unary minus, empty, $</a:t>
+              <a:t>%, missing operand, unbalanced ( [, unary minus, …; a / (b - b) exit 3</a:t>
             </a:r>
           </a:p>
         </p:txBody>
@@ -9698,7 +9698,7 @@
                 </a:solidFill>
                 <a:latin typeface="Calibri"/>
               </a:rPr>
-              <a:t>10</a:t>
+              <a:t>11</a:t>
             </a:r>
           </a:p>
         </p:txBody>
@@ -9861,7 +9861,7 @@
                 </a:solidFill>
                 <a:latin typeface="Calibri"/>
               </a:rPr>
-              <a:t>3,333</a:t>
+              <a:t>7,140</a:t>
             </a:r>
           </a:p>
         </p:txBody>
@@ -9900,7 +9900,7 @@
                 </a:solidFill>
                 <a:latin typeface="Calibri"/>
               </a:rPr>
-              <a:t>--exhaustive: every small tree, both targets, plus baseline comparison</a:t>
+              <a:t>--exhaustive: every small tree incl. DIV, both targets, plus baseline</a:t>
             </a:r>
           </a:p>
         </p:txBody>
@@ -10221,7 +10221,7 @@
                 </a:solidFill>
                 <a:latin typeface="Calibri"/>
               </a:rPr>
-              <a:t>6,666 / 6,666</a:t>
+              <a:t>13,692 / 13,692</a:t>
             </a:r>
           </a:p>
         </p:txBody>
@@ -10299,7 +10299,7 @@
                 </a:solidFill>
                 <a:latin typeface="Calibri"/>
               </a:rPr>
-              <a:t>−23.6%</a:t>
+              <a:t>−20.9%</a:t>
             </a:r>
           </a:p>
         </p:txBody>
@@ -10377,7 +10377,7 @@
                 </a:solidFill>
                 <a:latin typeface="Calibri"/>
               </a:rPr>
-              <a:t>−5.2%</a:t>
+              <a:t>−5.1%</a:t>
             </a:r>
           </a:p>
         </p:txBody>
@@ -10494,7 +10494,7 @@
                 </a:solidFill>
                 <a:latin typeface="Calibri"/>
               </a:rPr>
-              <a:t>≈10–17 ns per node up to 240k nodes</a:t>
+              <a:t>≈9–21 ns per node up to 240k nodes</a:t>
             </a:r>
           </a:p>
         </p:txBody>
@@ -11597,7 +11597,7 @@
                 </a:solidFill>
                 <a:latin typeface="Calibri"/>
               </a:rPr>
-              <a:t>/, unary minus rejected (exit 2)</a:t>
+              <a:t>%, unary minus rejected (exit 2)</a:t>
             </a:r>
           </a:p>
         </p:txBody>
@@ -11645,7 +11645,7 @@
                 </a:solidFill>
                 <a:latin typeface="Calibri"/>
               </a:rPr>
-              <a:t>new IR ops + rules per target</a:t>
+              <a:t>new IR op + rules per target (as done for DIV)</a:t>
             </a:r>
           </a:p>
         </p:txBody>
@@ -12340,7 +12340,7 @@
                 </a:solidFill>
                 <a:latin typeface="Consolas"/>
               </a:rPr>
-              <a:t>├── tests/          25 cases + expected/</a:t>
+              <a:t>├── tests/          31 cases + expected/</a:t>
             </a:r>
           </a:p>
           <a:p>
@@ -12919,7 +12919,7 @@
                 </a:solidFill>
                 <a:latin typeface="Calibri"/>
               </a:rPr>
-              <a:t>27 passed, 0 failed</a:t>
+              <a:t>33 passed, 0 failed</a:t>
             </a:r>
           </a:p>
         </p:txBody>
@@ -14040,7 +14040,7 @@
                 </a:solidFill>
                 <a:latin typeface="Calibri"/>
               </a:rPr>
-              <a:t>targetA.gr: 9 rules</a:t>
+              <a:t>targetA.gr: 11 rules</a:t>
             </a:r>
           </a:p>
           <a:p>
@@ -14056,7 +14056,7 @@
                 </a:solidFill>
                 <a:latin typeface="Calibri"/>
               </a:rPr>
-              <a:t>targetB.gr: 14 rules</a:t>
+              <a:t>targetB.gr: 17 rules</a:t>
             </a:r>
           </a:p>
           <a:p>
@@ -15036,7 +15036,7 @@
                 </a:solidFill>
                 <a:latin typeface="Calibri"/>
               </a:rPr>
-              <a:t>27/27, --exhaustive</a:t>
+              <a:t>33/33, --exhaustive</a:t>
             </a:r>
           </a:p>
         </p:txBody>
@@ -15792,7 +15792,7 @@
                 </a:solidFill>
                 <a:latin typeface="Calibri"/>
               </a:rPr>
-              <a:t>3,333 trees × 2 targets, 0 failures</a:t>
+              <a:t>7,140 trees incl. DIV × 2 targets, 0 failures</a:t>
             </a:r>
           </a:p>
         </p:txBody>
@@ -17178,7 +17178,7 @@
                 </a:solidFill>
                 <a:latin typeface="Calibri"/>
               </a:rPr>
-              <a:t>27 / 27</a:t>
+              <a:t>33 / 33</a:t>
             </a:r>
           </a:p>
         </p:txBody>
@@ -17256,7 +17256,7 @@
                 </a:solidFill>
                 <a:latin typeface="Calibri"/>
               </a:rPr>
-              <a:t>−23.6%</a:t>
+              <a:t>−20.9%</a:t>
             </a:r>
           </a:p>
         </p:txBody>
@@ -18791,7 +18791,7 @@
                 </a:solidFill>
                 <a:latin typeface="Consolas"/>
               </a:rPr>
-              <a:t>case 5: case 6: case 7: case 8: case 9:</a:t>
+              <a:t>case 5: case 6: ... case 11:  /* ADD..DIVI */</a:t>
             </a:r>
           </a:p>
           <a:p>
@@ -18995,7 +18995,7 @@
                 </a:solidFill>
                 <a:latin typeface="Consolas"/>
               </a:rPr>
-              <a:t>/* ADD, SUB, MUL: pop b, pop a, push a op b */</a:t>
+              <a:t>/* ADD..DIV: pop b, pop a, push a op b */</a:t>
             </a:r>
           </a:p>
           <a:p>
@@ -19027,7 +19027,7 @@
                 </a:solidFill>
                 <a:latin typeface="Consolas"/>
               </a:rPr>
-              <a:t>S[sp-2] = arith(op[0], S[sp-2], S[sp-1]);</a:t>
+              <a:t>if (!arith(op[0], S[sp-2], S[sp-1], &amp;S[sp-2]))</a:t>
             </a:r>
           </a:p>
           <a:p>
@@ -19043,6 +19043,22 @@
                 </a:solidFill>
                 <a:latin typeface="Consolas"/>
               </a:rPr>
+              <a:t>  return simfail(..., "division by zero");</a:t>
+            </a:r>
+          </a:p>
+          <a:p>
+            <a:pPr algn="l">
+              <a:spcAft>
+                <a:spcPts val="0"/>
+              </a:spcAft>
+            </a:pPr>
+            <a:r>
+              <a:rPr sz="1200" b="0" i="0">
+                <a:solidFill>
+                  <a:srgbClr val="E6EDF3"/>
+                </a:solidFill>
+                <a:latin typeface="Consolas"/>
+              </a:rPr>
               <a:t>sp--;</a:t>
             </a:r>
           </a:p>
@@ -19055,11 +19071,27 @@
             <a:r>
               <a:rPr sz="1200" b="0" i="0">
                 <a:solidFill>
+                  <a:srgbClr val="8FA3B8"/>
+                </a:solidFill>
+                <a:latin typeface="Consolas"/>
+              </a:rPr>
+              <a:t>/* ADDM/ADDI etc.: top op operand */</a:t>
+            </a:r>
+          </a:p>
+          <a:p>
+            <a:pPr algn="l">
+              <a:spcAft>
+                <a:spcPts val="0"/>
+              </a:spcAft>
+            </a:pPr>
+            <a:r>
+              <a:rPr sz="1200" b="0" i="0">
+                <a:solidFill>
                   <a:srgbClr val="E6EDF3"/>
                 </a:solidFill>
                 <a:latin typeface="Consolas"/>
               </a:rPr>
-              <a:t/>
+              <a:t>if (!operand_value(a[0], &amp;v) ||</a:t>
             </a:r>
           </a:p>
           <a:p>
@@ -19071,11 +19103,11 @@
             <a:r>
               <a:rPr sz="1200" b="0" i="0">
                 <a:solidFill>
-                  <a:srgbClr val="8FA3B8"/>
+                  <a:srgbClr val="E6EDF3"/>
                 </a:solidFill>
                 <a:latin typeface="Consolas"/>
               </a:rPr>
-              <a:t>/* ADDM/ADDI etc.: top op operand */</a:t>
+              <a:t>    (op[3] == 'M') != (a[0][0] == '['))</a:t>
             </a:r>
           </a:p>
           <a:p>
@@ -19091,7 +19123,7 @@
                 </a:solidFill>
                 <a:latin typeface="Consolas"/>
               </a:rPr>
-              <a:t>if (!operand_value(a[0], &amp;v) ||</a:t>
+              <a:t>  return simfail(..., "bad operand");</a:t>
             </a:r>
           </a:p>
           <a:p>
@@ -19107,55 +19139,7 @@
                 </a:solidFill>
                 <a:latin typeface="Consolas"/>
               </a:rPr>
-              <a:t>    (op[3] == 'M') != (a[0][0] == '['))</a:t>
-            </a:r>
-          </a:p>
-          <a:p>
-            <a:pPr algn="l">
-              <a:spcAft>
-                <a:spcPts val="0"/>
-              </a:spcAft>
-            </a:pPr>
-            <a:r>
-              <a:rPr sz="1200" b="0" i="0">
-                <a:solidFill>
-                  <a:srgbClr val="E6EDF3"/>
-                </a:solidFill>
-                <a:latin typeface="Consolas"/>
-              </a:rPr>
-              <a:t>  return simfail(..., "bad operand");</a:t>
-            </a:r>
-          </a:p>
-          <a:p>
-            <a:pPr algn="l">
-              <a:spcAft>
-                <a:spcPts val="0"/>
-              </a:spcAft>
-            </a:pPr>
-            <a:r>
-              <a:rPr sz="1200" b="0" i="0">
-                <a:solidFill>
-                  <a:srgbClr val="E6EDF3"/>
-                </a:solidFill>
-                <a:latin typeface="Consolas"/>
-              </a:rPr>
-              <a:t>S[sp-1] = arith(op[0], S[sp-1], v);</a:t>
-            </a:r>
-          </a:p>
-          <a:p>
-            <a:pPr algn="l">
-              <a:spcAft>
-                <a:spcPts val="0"/>
-              </a:spcAft>
-            </a:pPr>
-            <a:r>
-              <a:rPr sz="1200" b="0" i="0">
-                <a:solidFill>
-                  <a:srgbClr val="E6EDF3"/>
-                </a:solidFill>
-                <a:latin typeface="Consolas"/>
-              </a:rPr>
-              <a:t/>
+              <a:t>if (!arith(op[0], S[sp-1], v, &amp;S[sp-1])) ...</a:t>
             </a:r>
           </a:p>
           <a:p>
@@ -20160,7 +20144,7 @@
                 </a:solidFill>
                 <a:latin typeface="Calibri"/>
               </a:rPr>
-              <a:t>Expression-tree IR for CONST, VAR, ADD, SUB, MUL, LOAD</a:t>
+              <a:t>Expression-tree IR: CONST, VAR, ADD, SUB, MUL, DIV, LOAD</a:t>
             </a:r>
           </a:p>
         </p:txBody>
@@ -20252,7 +20236,7 @@
                 </a:solidFill>
                 <a:latin typeface="Calibri"/>
               </a:rPr>
-              <a:t>Target patterns, templates and costs (9 + 14 rules)</a:t>
+              <a:t>Target patterns, templates and costs (11 + 17 rules)</a:t>
             </a:r>
           </a:p>
         </p:txBody>
@@ -20712,7 +20696,7 @@
                 </a:solidFill>
                 <a:latin typeface="Calibri"/>
               </a:rPr>
-              <a:t>Reproducible tests and evidence: 27 / 27 pass</a:t>
+              <a:t>Reproducible tests and evidence: 33 / 33 pass</a:t>
             </a:r>
           </a:p>
         </p:txBody>
@@ -21114,7 +21098,7 @@
                 </a:solidFill>
                 <a:latin typeface="Consolas"/>
               </a:rPr>
-              <a:t>rule_mem_operand     | -t B    | a * b</a:t>
+              <a:t>rule_divm            | -t B    | a / b</a:t>
             </a:r>
           </a:p>
           <a:p>
@@ -21130,7 +21114,7 @@
                 </a:solidFill>
                 <a:latin typeface="Consolas"/>
               </a:rPr>
-              <a:t>neg_division         |         | a / b</a:t>
+              <a:t>neg_modulo           |         | a % b</a:t>
             </a:r>
           </a:p>
         </p:txBody>
@@ -22030,7 +22014,7 @@
                 </a:solidFill>
                 <a:latin typeface="Calibri"/>
               </a:rPr>
-              <a:t>--suite (10/10) and --exhaustive (0 failures)</a:t>
+              <a:t>--suite (11/11) and --exhaustive (0 failures)</a:t>
             </a:r>
           </a:p>
         </p:txBody>
@@ -22161,7 +22145,7 @@
                 </a:solidFill>
                 <a:latin typeface="Calibri"/>
               </a:rPr>
-              <a:t>27 passed, 0 failed; non-zero exit on any failure</a:t>
+              <a:t>33 passed, 0 failed; non-zero exit on any failure</a:t>
             </a:r>
           </a:p>
         </p:txBody>
@@ -22265,7 +22249,7 @@
                 </a:solidFill>
                 <a:latin typeface="Calibri"/>
               </a:rPr>
-              <a:t>Everything pending at Review 2 is done; scope is unchanged from Review 1</a:t>
+              <a:t>Everything pending at Review 2 is done; scope as in Review 1, plus a DIV operator</a:t>
             </a:r>
           </a:p>
         </p:txBody>
@@ -22616,7 +22600,7 @@
                 </a:solidFill>
                 <a:latin typeface="Calibri"/>
               </a:rPr>
-              <a:t>6 → 27</a:t>
+              <a:t>6 → 33</a:t>
             </a:r>
           </a:p>
         </p:txBody>
@@ -22915,7 +22899,7 @@
                           </a:solidFill>
                           <a:latin typeface="Calibri"/>
                         </a:rPr>
-                        <a:t>14-rule zero-address stack ISA with memory and immediate operands</a:t>
+                        <a:t>17-rule zero-address stack ISA with memory and immediate operands (incl. DIV)</a:t>
                       </a:r>
                     </a:p>
                   </a:txBody>
@@ -23128,7 +23112,7 @@
                           </a:solidFill>
                           <a:latin typeface="Calibri"/>
                         </a:rPr>
-                        <a:t>25 stored cases + 10-expression suite + 3,333-tree exhaustive check</a:t>
+                        <a:t>31 stored cases + 11-expression suite + 7,140-tree exhaustive check</a:t>
                       </a:r>
                     </a:p>
                   </a:txBody>
@@ -25058,7 +25042,7 @@
                 </a:solidFill>
                 <a:latin typeface="Calibri"/>
               </a:rPr>
-              <a:t>Same %term line: CONST=1 VAR=2 ADD=3 SUB=4 MUL=5 LOAD=6; different rules, nonterminals and costs</a:t>
+              <a:t>Same %term line: CONST=1 VAR=2 ADD=3 SUB=4 MUL=5 LOAD=6 DIV=7; different rules, nonterminals and costs</a:t>
             </a:r>
           </a:p>
         </p:txBody>
@@ -25285,7 +25269,7 @@
                 </a:solidFill>
                 <a:latin typeface="Calibri"/>
               </a:rPr>
-              <a:t>TARGET A · targetA.gr · register machine · 9 rules</a:t>
+              <a:t>TARGET A · targetA.gr · register machine · 11 rules</a:t>
             </a:r>
           </a:p>
         </p:txBody>
@@ -25453,6 +25437,38 @@
                 <a:latin typeface="Consolas"/>
               </a:rPr>
               <a:t>reg: MUL(reg,reg) = 9 (2);   MUL</a:t>
+            </a:r>
+          </a:p>
+          <a:p>
+            <a:pPr algn="l">
+              <a:spcAft>
+                <a:spcPts val="0"/>
+              </a:spcAft>
+            </a:pPr>
+            <a:r>
+              <a:rPr sz="1200" b="0" i="0">
+                <a:solidFill>
+                  <a:srgbClr val="E6EDF3"/>
+                </a:solidFill>
+                <a:latin typeface="Consolas"/>
+              </a:rPr>
+              <a:t>reg: DIV(reg,reg) = 10 (3);  DIV</a:t>
+            </a:r>
+          </a:p>
+          <a:p>
+            <a:pPr algn="l">
+              <a:spcAft>
+                <a:spcPts val="0"/>
+              </a:spcAft>
+            </a:pPr>
+            <a:r>
+              <a:rPr sz="1200" b="0" i="0">
+                <a:solidFill>
+                  <a:srgbClr val="E89A2C"/>
+                </a:solidFill>
+                <a:latin typeface="Consolas"/>
+              </a:rPr>
+              <a:t>reg: DIV(reg,imm) = 11 (3);  DIVI</a:t>
             </a:r>
           </a:p>
         </p:txBody>
@@ -25537,7 +25553,7 @@
                 </a:solidFill>
                 <a:latin typeface="Calibri"/>
               </a:rPr>
-              <a:t>TARGET B · targetB.gr · stack machine · 14 rules</a:t>
+              <a:t>TARGET B · targetB.gr · stack machine · 17 rules</a:t>
             </a:r>
           </a:p>
         </p:txBody>
@@ -25753,6 +25769,22 @@
                 <a:latin typeface="Consolas"/>
               </a:rPr>
               <a:t>stk: MUL(stk,imm) = 14 (2);   MULI  #k</a:t>
+            </a:r>
+          </a:p>
+          <a:p>
+            <a:pPr algn="l">
+              <a:spcAft>
+                <a:spcPts val="0"/>
+              </a:spcAft>
+            </a:pPr>
+            <a:r>
+              <a:rPr sz="1200" b="0" i="0">
+                <a:solidFill>
+                  <a:srgbClr val="E6EDF3"/>
+                </a:solidFill>
+                <a:latin typeface="Consolas"/>
+              </a:rPr>
+              <a:t>stk: DIV(stk, stk|mem|imm) 15-17 (3)</a:t>
             </a:r>
           </a:p>
         </p:txBody>
@@ -26759,7 +26791,7 @@
                 </a:solidFill>
                 <a:latin typeface="Consolas"/>
               </a:rPr>
-              <a:t>./build/burs "a / b"</a:t>
+              <a:t>./build/burs "a % b"</a:t>
             </a:r>
           </a:p>
           <a:p>
@@ -26807,7 +26839,7 @@
                 </a:solidFill>
                 <a:latin typeface="Consolas"/>
               </a:rPr>
-              <a:t>column 3: operator '/' is not</a:t>
+              <a:t>column 3: operator '%' is not</a:t>
             </a:r>
           </a:p>
           <a:p>

</xml_diff>